<commit_message>
Logos einbinden (Web-Header, PPTX-Layouts, DOCX-Kopf)
Co-Authored-By: Claude Sonnet 5.5 <noreply@anthropic.com>
Claude-Session: https://claude.ai/code/session_01LZiKgyJNCoBGmUkDiAUEHD
</commit_message>
<xml_diff>
--- a/templates/ruv.pptx
+++ b/templates/ruv.pptx
@@ -204,40 +204,30 @@
           </a:p>
         </p:txBody>
       </p:sp>
-      <p:sp>
-        <p:nvSpPr>
-          <p:cNvPr id="101" name="Logo-Platzhalter"/>
-          <p:cNvSpPr/>
+      <p:pic>
+        <p:nvPicPr>
+          <p:cNvPr id="101" name="Logo" descr="R+V"/>
+          <p:cNvPicPr>
+            <a:picLocks noChangeAspect="1"/>
+          </p:cNvPicPr>
           <p:nvPr userDrawn="1"/>
-        </p:nvSpPr>
-        <p:spPr>
-          <a:xfrm>
-            <a:off x="489857" y="6123214"/>
-            <a:ext cx="1959428" cy="391885"/>
+        </p:nvPicPr>
+        <p:blipFill>
+          <a:blip r:embed="rId2"/>
+          <a:stretch>
+            <a:fillRect/>
+          </a:stretch>
+        </p:blipFill>
+        <p:spPr>
+          <a:xfrm>
+            <a:off x="489857" y="5052774"/>
+            <a:ext cx="1959428" cy="1315368"/>
           </a:xfrm>
           <a:prstGeom prst="rect">
             <a:avLst/>
           </a:prstGeom>
-          <a:noFill/>
-          <a:ln>
-            <a:noFill/>
-          </a:ln>
-        </p:spPr>
-        <p:txBody>
-          <a:bodyPr wrap="square" lIns="0" tIns="0" rIns="0" bIns="0" anchor="ctr"/>
-          <a:lstStyle/>
-          <a:p>
-            <a:r>
-              <a:rPr lang="de-DE" sz="2400" b="1">
-                <a:solidFill>
-                  <a:srgbClr val="FFFFFF"/>
-                </a:solidFill>
-              </a:rPr>
-              <a:t>R+V</a:t>
-            </a:r>
-          </a:p>
-        </p:txBody>
-      </p:sp>
+        </p:spPr>
+      </p:pic>
     </p:spTree>
     <p:extLst>
       <p:ext uri="{BB962C8B-B14F-4D97-AF65-F5344CB8AC3E}">
@@ -379,40 +369,30 @@
           </a:p>
         </p:txBody>
       </p:sp>
-      <p:sp>
-        <p:nvSpPr>
-          <p:cNvPr id="102" name="Logo-Platzhalter"/>
-          <p:cNvSpPr/>
+      <p:pic>
+        <p:nvPicPr>
+          <p:cNvPr id="102" name="Logo" descr="R+V"/>
+          <p:cNvPicPr>
+            <a:picLocks noChangeAspect="1"/>
+          </p:cNvPicPr>
           <p:nvPr userDrawn="1"/>
-        </p:nvSpPr>
-        <p:spPr>
-          <a:xfrm>
-            <a:off x="489857" y="6123214"/>
-            <a:ext cx="1959428" cy="391885"/>
+        </p:nvPicPr>
+        <p:blipFill>
+          <a:blip r:embed="rId2"/>
+          <a:stretch>
+            <a:fillRect/>
+          </a:stretch>
+        </p:blipFill>
+        <p:spPr>
+          <a:xfrm>
+            <a:off x="10526486" y="5774864"/>
+            <a:ext cx="1175656" cy="789220"/>
           </a:xfrm>
           <a:prstGeom prst="rect">
             <a:avLst/>
           </a:prstGeom>
-          <a:noFill/>
-          <a:ln>
-            <a:noFill/>
-          </a:ln>
-        </p:spPr>
-        <p:txBody>
-          <a:bodyPr wrap="square" lIns="0" tIns="0" rIns="0" bIns="0" anchor="ctr"/>
-          <a:lstStyle/>
-          <a:p>
-            <a:r>
-              <a:rPr lang="de-DE" sz="2400" b="1">
-                <a:solidFill>
-                  <a:srgbClr val="001957"/>
-                </a:solidFill>
-              </a:rPr>
-              <a:t>R+V</a:t>
-            </a:r>
-          </a:p>
-        </p:txBody>
-      </p:sp>
+        </p:spPr>
+      </p:pic>
       <p:sp>
         <p:nvSpPr>
           <p:cNvPr id="103" name="Akzent"/>
@@ -547,40 +527,30 @@
           </a:p>
         </p:txBody>
       </p:sp>
-      <p:sp>
-        <p:nvSpPr>
-          <p:cNvPr id="104" name="Logo-Platzhalter"/>
-          <p:cNvSpPr/>
+      <p:pic>
+        <p:nvPicPr>
+          <p:cNvPr id="104" name="Logo" descr="R+V"/>
+          <p:cNvPicPr>
+            <a:picLocks noChangeAspect="1"/>
+          </p:cNvPicPr>
           <p:nvPr userDrawn="1"/>
-        </p:nvSpPr>
-        <p:spPr>
-          <a:xfrm>
-            <a:off x="489857" y="6123214"/>
-            <a:ext cx="1959428" cy="391885"/>
+        </p:nvPicPr>
+        <p:blipFill>
+          <a:blip r:embed="rId2"/>
+          <a:stretch>
+            <a:fillRect/>
+          </a:stretch>
+        </p:blipFill>
+        <p:spPr>
+          <a:xfrm>
+            <a:off x="489857" y="5052774"/>
+            <a:ext cx="1959428" cy="1315368"/>
           </a:xfrm>
           <a:prstGeom prst="rect">
             <a:avLst/>
           </a:prstGeom>
-          <a:noFill/>
-          <a:ln>
-            <a:noFill/>
-          </a:ln>
-        </p:spPr>
-        <p:txBody>
-          <a:bodyPr wrap="square" lIns="0" tIns="0" rIns="0" bIns="0" anchor="ctr"/>
-          <a:lstStyle/>
-          <a:p>
-            <a:r>
-              <a:rPr lang="de-DE" sz="2400" b="1">
-                <a:solidFill>
-                  <a:srgbClr val="FFFFFF"/>
-                </a:solidFill>
-              </a:rPr>
-              <a:t>R+V</a:t>
-            </a:r>
-          </a:p>
-        </p:txBody>
-      </p:sp>
+        </p:spPr>
+      </p:pic>
     </p:spTree>
     <p:extLst>
       <p:ext uri="{BB962C8B-B14F-4D97-AF65-F5344CB8AC3E}">
@@ -788,40 +758,30 @@
           </a:p>
         </p:txBody>
       </p:sp>
-      <p:sp>
-        <p:nvSpPr>
-          <p:cNvPr id="105" name="Logo-Platzhalter"/>
-          <p:cNvSpPr/>
+      <p:pic>
+        <p:nvPicPr>
+          <p:cNvPr id="105" name="Logo" descr="R+V"/>
+          <p:cNvPicPr>
+            <a:picLocks noChangeAspect="1"/>
+          </p:cNvPicPr>
           <p:nvPr userDrawn="1"/>
-        </p:nvSpPr>
-        <p:spPr>
-          <a:xfrm>
-            <a:off x="489857" y="6123214"/>
-            <a:ext cx="1959428" cy="391885"/>
+        </p:nvPicPr>
+        <p:blipFill>
+          <a:blip r:embed="rId2"/>
+          <a:stretch>
+            <a:fillRect/>
+          </a:stretch>
+        </p:blipFill>
+        <p:spPr>
+          <a:xfrm>
+            <a:off x="10526486" y="5774864"/>
+            <a:ext cx="1175656" cy="789220"/>
           </a:xfrm>
           <a:prstGeom prst="rect">
             <a:avLst/>
           </a:prstGeom>
-          <a:noFill/>
-          <a:ln>
-            <a:noFill/>
-          </a:ln>
-        </p:spPr>
-        <p:txBody>
-          <a:bodyPr wrap="square" lIns="0" tIns="0" rIns="0" bIns="0" anchor="ctr"/>
-          <a:lstStyle/>
-          <a:p>
-            <a:r>
-              <a:rPr lang="de-DE" sz="2400" b="1">
-                <a:solidFill>
-                  <a:srgbClr val="001957"/>
-                </a:solidFill>
-              </a:rPr>
-              <a:t>R+V</a:t>
-            </a:r>
-          </a:p>
-        </p:txBody>
-      </p:sp>
+        </p:spPr>
+      </p:pic>
       <p:sp>
         <p:nvSpPr>
           <p:cNvPr id="106" name="Akzent"/>
@@ -919,40 +879,30 @@
           </a:p>
         </p:txBody>
       </p:sp>
-      <p:sp>
-        <p:nvSpPr>
-          <p:cNvPr id="107" name="Logo-Platzhalter"/>
-          <p:cNvSpPr/>
+      <p:pic>
+        <p:nvPicPr>
+          <p:cNvPr id="107" name="Logo" descr="R+V"/>
+          <p:cNvPicPr>
+            <a:picLocks noChangeAspect="1"/>
+          </p:cNvPicPr>
           <p:nvPr userDrawn="1"/>
-        </p:nvSpPr>
-        <p:spPr>
-          <a:xfrm>
-            <a:off x="489857" y="6123214"/>
-            <a:ext cx="1959428" cy="391885"/>
+        </p:nvPicPr>
+        <p:blipFill>
+          <a:blip r:embed="rId2"/>
+          <a:stretch>
+            <a:fillRect/>
+          </a:stretch>
+        </p:blipFill>
+        <p:spPr>
+          <a:xfrm>
+            <a:off x="10526486" y="5774864"/>
+            <a:ext cx="1175656" cy="789220"/>
           </a:xfrm>
           <a:prstGeom prst="rect">
             <a:avLst/>
           </a:prstGeom>
-          <a:noFill/>
-          <a:ln>
-            <a:noFill/>
-          </a:ln>
-        </p:spPr>
-        <p:txBody>
-          <a:bodyPr wrap="square" lIns="0" tIns="0" rIns="0" bIns="0" anchor="ctr"/>
-          <a:lstStyle/>
-          <a:p>
-            <a:r>
-              <a:rPr lang="de-DE" sz="2400" b="1">
-                <a:solidFill>
-                  <a:srgbClr val="001957"/>
-                </a:solidFill>
-              </a:rPr>
-              <a:t>R+V</a:t>
-            </a:r>
-          </a:p>
-        </p:txBody>
-      </p:sp>
+        </p:spPr>
+      </p:pic>
       <p:sp>
         <p:nvSpPr>
           <p:cNvPr id="108" name="Akzent"/>

</xml_diff>

<commit_message>
PPTX: Startseite und Inhaltsseiten nach R+V-Vorlage, Praesentationsregeln, new_deck.py
Co-Authored-By: Claude Sonnet 5.5 <noreply@anthropic.com>
Claude-Session: https://claude.ai/code/session_01LZiKgyJNCoBGmUkDiAUEHD
</commit_message>
<xml_diff>
--- a/templates/ruv.pptx
+++ b/templates/ruv.pptx
@@ -107,11 +107,11 @@
 
 <file path=ppt/slideLayouts/slideLayout1.xml><?xml version="1.0" encoding="utf-8"?>
 <p:sldLayout xmlns:a="http://schemas.openxmlformats.org/drawingml/2006/main" xmlns:r="http://schemas.openxmlformats.org/officeDocument/2006/relationships" xmlns:p="http://schemas.openxmlformats.org/presentationml/2006/main" type="title" preserve="1">
-  <p:cSld name="Titelfolie">
+  <p:cSld name="Startseite">
     <p:bg>
       <p:bgPr>
         <a:solidFill>
-          <a:srgbClr val="001957"/>
+          <a:srgbClr val="FFFFFF"/>
         </a:solidFill>
         <a:effectLst/>
       </p:bgPr>
@@ -132,26 +132,48 @@
       </p:grpSpPr>
       <p:sp>
         <p:nvSpPr>
-          <p:cNvPr id="2" name="Title 1"/>
+          <p:cNvPr id="101" name="Dunkelblaue Fläche"/>
+          <p:cNvSpPr/>
+          <p:nvPr userDrawn="1"/>
+        </p:nvSpPr>
+        <p:spPr>
+          <a:xfrm>
+            <a:off x="0" y="0"/>
+            <a:ext cx="6109417" cy="6858000"/>
+          </a:xfrm>
+          <a:prstGeom prst="rect">
+            <a:avLst/>
+          </a:prstGeom>
+          <a:solidFill>
+            <a:srgbClr val="001957"/>
+          </a:solidFill>
+          <a:ln>
+            <a:noFill/>
+          </a:ln>
+        </p:spPr>
+      </p:sp>
+      <p:sp>
+        <p:nvSpPr>
+          <p:cNvPr id="102" name="Bild"/>
           <p:cNvSpPr>
             <a:spLocks noGrp="1"/>
           </p:cNvSpPr>
           <p:nvPr>
-            <p:ph type="ctrTitle"/>
+            <p:ph type="pic" idx="14"/>
           </p:nvPr>
         </p:nvSpPr>
         <p:spPr>
           <a:xfrm>
-            <a:off x="489857" y="1469571"/>
-            <a:ext cx="4898570" cy="1959428"/>
-          </a:xfrm>
-        </p:spPr>
-        <p:txBody>
-          <a:bodyPr anchor="b"/>
+            <a:off x="6109417" y="0"/>
+            <a:ext cx="6082582" cy="6858000"/>
+          </a:xfrm>
+        </p:spPr>
+        <p:txBody>
+          <a:bodyPr anchor="ctr"/>
           <a:lstStyle>
-            <a:lvl1pPr marL="0" indent="0" algn="l">
+            <a:lvl1pPr marL="0" indent="0" algn="ctr">
               <a:buNone/>
-              <a:defRPr sz="4400" b="1">
+              <a:defRPr sz="1400">
                 <a:solidFill>
                   <a:srgbClr val="FFFFFF"/>
                 </a:solidFill>
@@ -160,53 +182,15 @@
           </a:lstStyle>
           <a:p>
             <a:r>
-              <a:rPr lang="en-US" smtClean="0"/>
-              <a:t>Click to edit Master title style</a:t>
-            </a:r>
-            <a:endParaRPr lang="en-US"/>
-          </a:p>
-        </p:txBody>
-      </p:sp>
-      <p:sp>
-        <p:nvSpPr>
-          <p:cNvPr id="3" name="Subtitle 2"/>
-          <p:cNvSpPr>
-            <a:spLocks noGrp="1"/>
-          </p:cNvSpPr>
-          <p:nvPr>
-            <p:ph type="subTitle" idx="1"/>
-          </p:nvPr>
-        </p:nvSpPr>
-        <p:spPr>
-          <a:xfrm>
-            <a:off x="489857" y="3575956"/>
-            <a:ext cx="4898570" cy="979714"/>
-          </a:xfrm>
-        </p:spPr>
-        <p:txBody>
-          <a:bodyPr/>
-          <a:lstStyle>
-            <a:lvl1pPr marL="0" indent="0" algn="l">
-              <a:buNone/>
-              <a:defRPr sz="2000" b="0">
-                <a:solidFill>
-                  <a:srgbClr val="F79506"/>
-                </a:solidFill>
-              </a:defRPr>
-            </a:lvl1pPr>
-          </a:lstStyle>
-          <a:p>
-            <a:r>
-              <a:rPr lang="en-US" smtClean="0"/>
-              <a:t>Click to edit Master subtitle style</a:t>
-            </a:r>
-            <a:endParaRPr lang="en-US"/>
+              <a:rPr lang="de-DE"/>
+              <a:t>Bild zum Thema der Präsentation einfügen</a:t>
+            </a:r>
           </a:p>
         </p:txBody>
       </p:sp>
       <p:pic>
         <p:nvPicPr>
-          <p:cNvPr id="101" name="Logo" descr="R+V"/>
+          <p:cNvPr id="103" name="Logo" descr="R+V Logo"/>
           <p:cNvPicPr>
             <a:picLocks noChangeAspect="1"/>
           </p:cNvPicPr>
@@ -220,14 +204,215 @@
         </p:blipFill>
         <p:spPr>
           <a:xfrm>
-            <a:off x="489857" y="5052774"/>
-            <a:ext cx="1959428" cy="1315368"/>
+            <a:off x="59969" y="69201"/>
+            <a:ext cx="2876628" cy="1950256"/>
           </a:xfrm>
           <a:prstGeom prst="rect">
             <a:avLst/>
           </a:prstGeom>
         </p:spPr>
       </p:pic>
+      <p:sp>
+        <p:nvSpPr>
+          <p:cNvPr id="104" name="Ort, Datum, Referentin oder Referent"/>
+          <p:cNvSpPr>
+            <a:spLocks noGrp="1"/>
+          </p:cNvSpPr>
+          <p:nvPr>
+            <p:ph type="body" sz="quarter" idx="13"/>
+          </p:nvPr>
+        </p:nvSpPr>
+        <p:spPr>
+          <a:xfrm>
+            <a:off x="527753" y="2503170"/>
+            <a:ext cx="5170195" cy="274320"/>
+          </a:xfrm>
+        </p:spPr>
+        <p:txBody>
+          <a:bodyPr lIns="36000" tIns="0" rIns="36000" bIns="0" anchor="ctr">
+            <a:normAutofit/>
+          </a:bodyPr>
+          <a:lstStyle>
+            <a:lvl1pPr marL="0" indent="0" algn="l">
+              <a:spcBef>
+                <a:spcPts val="0"/>
+              </a:spcBef>
+              <a:buNone/>
+              <a:defRPr sz="2000" b="0">
+                <a:solidFill>
+                  <a:srgbClr val="FFFFFF"/>
+                </a:solidFill>
+              </a:defRPr>
+            </a:lvl1pPr>
+          </a:lstStyle>
+          <a:p>
+            <a:r>
+              <a:rPr lang="de-DE"/>
+              <a:t>Ort, Datum, Referentin oder Referent</a:t>
+            </a:r>
+          </a:p>
+        </p:txBody>
+      </p:sp>
+      <p:sp>
+        <p:nvSpPr>
+          <p:cNvPr id="105" name="Haupttitel"/>
+          <p:cNvSpPr>
+            <a:spLocks noGrp="1"/>
+          </p:cNvSpPr>
+          <p:nvPr>
+            <p:ph type="ctrTitle"/>
+          </p:nvPr>
+        </p:nvSpPr>
+        <p:spPr>
+          <a:xfrm>
+            <a:off x="527753" y="2815209"/>
+            <a:ext cx="5170195" cy="932688"/>
+          </a:xfrm>
+        </p:spPr>
+        <p:txBody>
+          <a:bodyPr lIns="36000" tIns="0" rIns="36000" bIns="0" anchor="t">
+            <a:normAutofit/>
+          </a:bodyPr>
+          <a:lstStyle>
+            <a:lvl1pPr marL="0" indent="0" algn="l">
+              <a:lnSpc>
+                <a:spcPct val="95000"/>
+              </a:lnSpc>
+              <a:spcBef>
+                <a:spcPts val="0"/>
+              </a:spcBef>
+              <a:buNone/>
+              <a:defRPr sz="3600" b="1">
+                <a:solidFill>
+                  <a:srgbClr val="F79506"/>
+                </a:solidFill>
+              </a:defRPr>
+            </a:lvl1pPr>
+          </a:lstStyle>
+          <a:p>
+            <a:r>
+              <a:rPr lang="de-DE"/>
+              <a:t>Haupttitel</a:t>
+            </a:r>
+          </a:p>
+        </p:txBody>
+      </p:sp>
+      <p:sp>
+        <p:nvSpPr>
+          <p:cNvPr id="106" name="Untertitel"/>
+          <p:cNvSpPr>
+            <a:spLocks noGrp="1"/>
+          </p:cNvSpPr>
+          <p:nvPr>
+            <p:ph type="subTitle" idx="1"/>
+          </p:nvPr>
+        </p:nvSpPr>
+        <p:spPr>
+          <a:xfrm>
+            <a:off x="527753" y="3819906"/>
+            <a:ext cx="5170195" cy="918972"/>
+          </a:xfrm>
+        </p:spPr>
+        <p:txBody>
+          <a:bodyPr lIns="36000" tIns="0" rIns="36000" bIns="0" anchor="t">
+            <a:normAutofit/>
+          </a:bodyPr>
+          <a:lstStyle>
+            <a:lvl1pPr marL="0" indent="0" algn="l">
+              <a:lnSpc>
+                <a:spcPct val="95000"/>
+              </a:lnSpc>
+              <a:spcBef>
+                <a:spcPts val="0"/>
+              </a:spcBef>
+              <a:buNone/>
+              <a:defRPr sz="3200" b="1">
+                <a:solidFill>
+                  <a:srgbClr val="FFFFFF"/>
+                </a:solidFill>
+              </a:defRPr>
+            </a:lvl1pPr>
+          </a:lstStyle>
+          <a:p>
+            <a:r>
+              <a:rPr lang="de-DE"/>
+              <a:t>Untertitel</a:t>
+            </a:r>
+          </a:p>
+        </p:txBody>
+      </p:sp>
+      <p:sp>
+        <p:nvSpPr>
+          <p:cNvPr id="107" name="Die Versicherung in der"/>
+          <p:cNvSpPr txBox="1"/>
+          <p:nvPr userDrawn="1"/>
+        </p:nvSpPr>
+        <p:spPr>
+          <a:xfrm>
+            <a:off x="536698" y="5901309"/>
+            <a:ext cx="2683492" cy="205740"/>
+          </a:xfrm>
+          <a:prstGeom prst="rect">
+            <a:avLst/>
+          </a:prstGeom>
+          <a:noFill/>
+        </p:spPr>
+        <p:txBody>
+          <a:bodyPr wrap="square" lIns="0" tIns="0" rIns="0" bIns="0" anchor="t"/>
+          <a:lstStyle/>
+          <a:p>
+            <a:r>
+              <a:rPr lang="de-DE" sz="1100" b="1">
+                <a:solidFill>
+                  <a:srgbClr val="FFFFFF"/>
+                </a:solidFill>
+              </a:rPr>
+              <a:t>Die Versicherung in der</a:t>
+            </a:r>
+          </a:p>
+        </p:txBody>
+      </p:sp>
+      <p:sp>
+        <p:nvSpPr>
+          <p:cNvPr id="108" name="Logo Genossenschaftliche Finanzgruppe (Platzhalter)"/>
+          <p:cNvSpPr txBox="1"/>
+          <p:nvPr userDrawn="1"/>
+        </p:nvSpPr>
+        <p:spPr>
+          <a:xfrm>
+            <a:off x="536698" y="6137910"/>
+            <a:ext cx="2683492" cy="274320"/>
+          </a:xfrm>
+          <a:prstGeom prst="rect">
+            <a:avLst/>
+          </a:prstGeom>
+          <a:noFill/>
+        </p:spPr>
+        <p:txBody>
+          <a:bodyPr wrap="square" lIns="0" tIns="0" rIns="0" bIns="0" anchor="t"/>
+          <a:lstStyle/>
+          <a:p>
+            <a:r>
+              <a:rPr lang="de-DE" sz="800" b="0">
+                <a:solidFill>
+                  <a:srgbClr val="FFFFFF"/>
+                </a:solidFill>
+              </a:rPr>
+              <a:t>Genossenschaftliche Finanzgruppe</a:t>
+            </a:r>
+          </a:p>
+          <a:p>
+            <a:r>
+              <a:rPr lang="de-DE" sz="800" b="0">
+                <a:solidFill>
+                  <a:srgbClr val="FFFFFF"/>
+                </a:solidFill>
+              </a:rPr>
+              <a:t>Volksbanken Raiffeisenbanken</a:t>
+            </a:r>
+          </a:p>
+        </p:txBody>
+      </p:sp>
     </p:spTree>
     <p:extLst>
       <p:ext uri="{BB962C8B-B14F-4D97-AF65-F5344CB8AC3E}">
@@ -268,7 +453,7 @@
       </p:grpSpPr>
       <p:sp>
         <p:nvSpPr>
-          <p:cNvPr id="2" name="Title 1"/>
+          <p:cNvPr id="109" name="Hauptheadline"/>
           <p:cNvSpPr>
             <a:spLocks noGrp="1"/>
           </p:cNvSpPr>
@@ -278,16 +463,21 @@
         </p:nvSpPr>
         <p:spPr>
           <a:xfrm>
-            <a:off x="489857" y="391885"/>
-            <a:ext cx="11212286" cy="783771"/>
-          </a:xfrm>
-        </p:spPr>
-        <p:txBody>
-          <a:bodyPr anchor="t"/>
+            <a:off x="512117" y="268239"/>
+            <a:ext cx="11122841" cy="402359"/>
+          </a:xfrm>
+        </p:spPr>
+        <p:txBody>
+          <a:bodyPr lIns="36000" tIns="0" rIns="36000" bIns="0" anchor="b">
+            <a:normAutofit/>
+          </a:bodyPr>
           <a:lstStyle>
             <a:lvl1pPr marL="0" indent="0" algn="l">
+              <a:spcBef>
+                <a:spcPts val="0"/>
+              </a:spcBef>
               <a:buNone/>
-              <a:defRPr sz="3200" b="1">
+              <a:defRPr sz="2800" b="1">
                 <a:solidFill>
                   <a:srgbClr val="001957"/>
                 </a:solidFill>
@@ -296,16 +486,56 @@
           </a:lstStyle>
           <a:p>
             <a:r>
-              <a:rPr lang="en-US" smtClean="0"/>
-              <a:t>Click to edit Master title style</a:t>
-            </a:r>
-            <a:endParaRPr lang="en-US"/>
-          </a:p>
-        </p:txBody>
-      </p:sp>
-      <p:sp>
-        <p:nvSpPr>
-          <p:cNvPr id="3" name="Content Placeholder 2"/>
+              <a:rPr lang="de-DE"/>
+              <a:t>Hauptheadline</a:t>
+            </a:r>
+          </a:p>
+        </p:txBody>
+      </p:sp>
+      <p:sp>
+        <p:nvSpPr>
+          <p:cNvPr id="110" name="Unterheadline"/>
+          <p:cNvSpPr>
+            <a:spLocks noGrp="1"/>
+          </p:cNvSpPr>
+          <p:nvPr>
+            <p:ph type="body" sz="quarter" idx="13"/>
+          </p:nvPr>
+        </p:nvSpPr>
+        <p:spPr>
+          <a:xfrm>
+            <a:off x="512117" y="679541"/>
+            <a:ext cx="11122841" cy="330829"/>
+          </a:xfrm>
+        </p:spPr>
+        <p:txBody>
+          <a:bodyPr lIns="36000" tIns="0" rIns="36000" bIns="0" anchor="t">
+            <a:normAutofit/>
+          </a:bodyPr>
+          <a:lstStyle>
+            <a:lvl1pPr marL="0" indent="0" algn="l">
+              <a:spcBef>
+                <a:spcPts val="0"/>
+              </a:spcBef>
+              <a:buNone/>
+              <a:defRPr sz="2800" b="1">
+                <a:solidFill>
+                  <a:srgbClr val="EB6504"/>
+                </a:solidFill>
+              </a:defRPr>
+            </a:lvl1pPr>
+          </a:lstStyle>
+          <a:p>
+            <a:r>
+              <a:rPr lang="de-DE"/>
+              <a:t>Unterheadline</a:t>
+            </a:r>
+          </a:p>
+        </p:txBody>
+      </p:sp>
+      <p:sp>
+        <p:nvSpPr>
+          <p:cNvPr id="111" name="Inhalt"/>
           <p:cNvSpPr>
             <a:spLocks noGrp="1"/>
           </p:cNvSpPr>
@@ -315,14 +545,19 @@
         </p:nvSpPr>
         <p:spPr>
           <a:xfrm>
-            <a:off x="489857" y="1469571"/>
-            <a:ext cx="11212286" cy="3918856"/>
-          </a:xfrm>
-        </p:spPr>
-        <p:txBody>
-          <a:bodyPr/>
+            <a:off x="512117" y="1341199"/>
+            <a:ext cx="11122841" cy="4738904"/>
+          </a:xfrm>
+        </p:spPr>
+        <p:txBody>
+          <a:bodyPr lIns="36000" tIns="0" rIns="36000" bIns="0" anchor="t">
+            <a:normAutofit/>
+          </a:bodyPr>
           <a:lstStyle>
             <a:lvl1pPr marL="0" indent="0" algn="l">
+              <a:spcBef>
+                <a:spcPts val="0"/>
+              </a:spcBef>
               <a:buNone/>
               <a:defRPr sz="1800" b="0">
                 <a:solidFill>
@@ -332,46 +567,88 @@
             </a:lvl1pPr>
           </a:lstStyle>
           <a:p>
-            <a:pPr lvl="0"/>
-            <a:r>
-              <a:rPr lang="en-US" smtClean="0"/>
-              <a:t>Click to edit Master text styles</a:t>
-            </a:r>
-          </a:p>
-          <a:p>
-            <a:pPr lvl="1"/>
-            <a:r>
-              <a:rPr lang="en-US" smtClean="0"/>
-              <a:t>Second level</a:t>
-            </a:r>
-          </a:p>
-          <a:p>
-            <a:pPr lvl="2"/>
-            <a:r>
-              <a:rPr lang="en-US" smtClean="0"/>
-              <a:t>Third level</a:t>
-            </a:r>
-          </a:p>
-          <a:p>
-            <a:pPr lvl="3"/>
-            <a:r>
-              <a:rPr lang="en-US" smtClean="0"/>
-              <a:t>Fourth level</a:t>
-            </a:r>
-          </a:p>
-          <a:p>
-            <a:pPr lvl="4"/>
-            <a:r>
-              <a:rPr lang="en-US" smtClean="0"/>
-              <a:t>Fifth level</a:t>
-            </a:r>
-            <a:endParaRPr lang="en-US"/>
+            <a:r>
+              <a:rPr lang="de-DE"/>
+              <a:t>Inhalt</a:t>
+            </a:r>
+          </a:p>
+        </p:txBody>
+      </p:sp>
+      <p:sp>
+        <p:nvSpPr>
+          <p:cNvPr id="113" name="Foliennummer"/>
+          <p:cNvSpPr txBox="1"/>
+          <p:nvPr userDrawn="1"/>
+        </p:nvSpPr>
+        <p:spPr>
+          <a:xfrm>
+            <a:off x="521102" y="6209919"/>
+            <a:ext cx="359380" cy="219456"/>
+          </a:xfrm>
+          <a:prstGeom prst="rect">
+            <a:avLst/>
+          </a:prstGeom>
+          <a:noFill/>
+        </p:spPr>
+        <p:txBody>
+          <a:bodyPr wrap="square" lIns="0" tIns="0" rIns="0" bIns="0" anchor="t"/>
+          <a:lstStyle/>
+          <a:p>
+            <a:fld id="{B6F15528-21DE-4FAA-801E-634DDDAF4B112}" type="slidenum">
+              <a:rPr lang="de-DE" sz="1100" b="1">
+                <a:solidFill>
+                  <a:srgbClr val="001957"/>
+                </a:solidFill>
+              </a:rPr>
+              <a:t>‹#›</a:t>
+            </a:fld>
+          </a:p>
+        </p:txBody>
+      </p:sp>
+      <p:sp>
+        <p:nvSpPr>
+          <p:cNvPr id="115" name="Titel der Präsentation"/>
+          <p:cNvSpPr txBox="1"/>
+          <p:nvPr userDrawn="1"/>
+        </p:nvSpPr>
+        <p:spPr>
+          <a:xfrm>
+            <a:off x="997282" y="6209919"/>
+            <a:ext cx="6289167" cy="360045"/>
+          </a:xfrm>
+          <a:prstGeom prst="rect">
+            <a:avLst/>
+          </a:prstGeom>
+          <a:noFill/>
+        </p:spPr>
+        <p:txBody>
+          <a:bodyPr wrap="square" lIns="0" tIns="0" rIns="0" bIns="0" anchor="t"/>
+          <a:lstStyle/>
+          <a:p>
+            <a:r>
+              <a:rPr lang="de-DE" sz="1100" b="1">
+                <a:solidFill>
+                  <a:srgbClr val="001957"/>
+                </a:solidFill>
+              </a:rPr>
+              <a:t>Titel der Präsentation</a:t>
+            </a:r>
+          </a:p>
+          <a:p>
+            <a:fld id="{B6F15528-21DE-4FAA-801E-634DDDAF4B114}" type="datetime1">
+              <a:rPr lang="de-DE" sz="1100" b="0">
+                <a:solidFill>
+                  <a:srgbClr val="001957"/>
+                </a:solidFill>
+              </a:rPr>
+              <a:t>01.01.2026</a:t>
+            </a:fld>
           </a:p>
         </p:txBody>
       </p:sp>
       <p:pic>
         <p:nvPicPr>
-          <p:cNvPr id="102" name="Logo" descr="R+V"/>
+          <p:cNvPr id="116" name="Logo" descr="R+V Logo"/>
           <p:cNvPicPr>
             <a:picLocks noChangeAspect="1"/>
           </p:cNvPicPr>
@@ -385,36 +662,14 @@
         </p:blipFill>
         <p:spPr>
           <a:xfrm>
-            <a:off x="10526486" y="5774864"/>
-            <a:ext cx="1175656" cy="789220"/>
+            <a:off x="10800097" y="6080996"/>
+            <a:ext cx="1040806" cy="698695"/>
           </a:xfrm>
           <a:prstGeom prst="rect">
             <a:avLst/>
           </a:prstGeom>
         </p:spPr>
       </p:pic>
-      <p:sp>
-        <p:nvSpPr>
-          <p:cNvPr id="103" name="Akzent"/>
-          <p:cNvSpPr/>
-          <p:nvPr userDrawn="1"/>
-        </p:nvSpPr>
-        <p:spPr>
-          <a:xfrm>
-            <a:off x="0" y="0"/>
-            <a:ext cx="171449" cy="6858000"/>
-          </a:xfrm>
-          <a:prstGeom prst="rect">
-            <a:avLst/>
-          </a:prstGeom>
-          <a:solidFill>
-            <a:srgbClr val="EB6504"/>
-          </a:solidFill>
-          <a:ln>
-            <a:noFill/>
-          </a:ln>
-        </p:spPr>
-      </p:sp>
     </p:spTree>
     <p:extLst>
       <p:ext uri="{BB962C8B-B14F-4D97-AF65-F5344CB8AC3E}">
@@ -453,83 +708,9 @@
           <a:chExt cx="0" cy="0"/>
         </a:xfrm>
       </p:grpSpPr>
-      <p:sp>
-        <p:nvSpPr>
-          <p:cNvPr id="2" name="Title 1"/>
-          <p:cNvSpPr>
-            <a:spLocks noGrp="1"/>
-          </p:cNvSpPr>
-          <p:nvPr>
-            <p:ph type="title"/>
-          </p:nvPr>
-        </p:nvSpPr>
-        <p:spPr>
-          <a:xfrm>
-            <a:off x="489857" y="1469571"/>
-            <a:ext cx="4898570" cy="1959428"/>
-          </a:xfrm>
-        </p:spPr>
-        <p:txBody>
-          <a:bodyPr anchor="b"/>
-          <a:lstStyle>
-            <a:lvl1pPr marL="0" indent="0" algn="l">
-              <a:buNone/>
-              <a:defRPr sz="4400" b="1">
-                <a:solidFill>
-                  <a:srgbClr val="FFFFFF"/>
-                </a:solidFill>
-              </a:defRPr>
-            </a:lvl1pPr>
-          </a:lstStyle>
-          <a:p>
-            <a:r>
-              <a:rPr lang="en-US" smtClean="0"/>
-              <a:t>Click to edit Master title style</a:t>
-            </a:r>
-            <a:endParaRPr lang="en-US"/>
-          </a:p>
-        </p:txBody>
-      </p:sp>
-      <p:sp>
-        <p:nvSpPr>
-          <p:cNvPr id="3" name="Text Placeholder 2"/>
-          <p:cNvSpPr>
-            <a:spLocks noGrp="1"/>
-          </p:cNvSpPr>
-          <p:nvPr>
-            <p:ph type="body" idx="1"/>
-          </p:nvPr>
-        </p:nvSpPr>
-        <p:spPr>
-          <a:xfrm>
-            <a:off x="489857" y="3575956"/>
-            <a:ext cx="4898570" cy="979714"/>
-          </a:xfrm>
-        </p:spPr>
-        <p:txBody>
-          <a:bodyPr anchor="b"/>
-          <a:lstStyle>
-            <a:lvl1pPr marL="0" indent="0" algn="l">
-              <a:buNone/>
-              <a:defRPr sz="2000" b="0">
-                <a:solidFill>
-                  <a:srgbClr val="F79506"/>
-                </a:solidFill>
-              </a:defRPr>
-            </a:lvl1pPr>
-          </a:lstStyle>
-          <a:p>
-            <a:pPr lvl="0"/>
-            <a:r>
-              <a:rPr lang="en-US" smtClean="0"/>
-              <a:t>Click to edit Master text styles</a:t>
-            </a:r>
-          </a:p>
-        </p:txBody>
-      </p:sp>
       <p:pic>
         <p:nvPicPr>
-          <p:cNvPr id="104" name="Logo" descr="R+V"/>
+          <p:cNvPr id="117" name="Logo" descr="R+V Logo"/>
           <p:cNvPicPr>
             <a:picLocks noChangeAspect="1"/>
           </p:cNvPicPr>
@@ -543,14 +724,102 @@
         </p:blipFill>
         <p:spPr>
           <a:xfrm>
-            <a:off x="489857" y="5052774"/>
-            <a:ext cx="1959428" cy="1315368"/>
+            <a:off x="59969" y="69201"/>
+            <a:ext cx="2876628" cy="1950256"/>
           </a:xfrm>
           <a:prstGeom prst="rect">
             <a:avLst/>
           </a:prstGeom>
         </p:spPr>
       </p:pic>
+      <p:sp>
+        <p:nvSpPr>
+          <p:cNvPr id="118" name="Haupttitel"/>
+          <p:cNvSpPr>
+            <a:spLocks noGrp="1"/>
+          </p:cNvSpPr>
+          <p:nvPr>
+            <p:ph type="title"/>
+          </p:nvPr>
+        </p:nvSpPr>
+        <p:spPr>
+          <a:xfrm>
+            <a:off x="527753" y="2815209"/>
+            <a:ext cx="8050476" cy="932688"/>
+          </a:xfrm>
+        </p:spPr>
+        <p:txBody>
+          <a:bodyPr lIns="36000" tIns="0" rIns="36000" bIns="0" anchor="t">
+            <a:normAutofit/>
+          </a:bodyPr>
+          <a:lstStyle>
+            <a:lvl1pPr marL="0" indent="0" algn="l">
+              <a:lnSpc>
+                <a:spcPct val="95000"/>
+              </a:lnSpc>
+              <a:spcBef>
+                <a:spcPts val="0"/>
+              </a:spcBef>
+              <a:buNone/>
+              <a:defRPr sz="3600" b="1">
+                <a:solidFill>
+                  <a:srgbClr val="F79506"/>
+                </a:solidFill>
+              </a:defRPr>
+            </a:lvl1pPr>
+          </a:lstStyle>
+          <a:p>
+            <a:r>
+              <a:rPr lang="de-DE"/>
+              <a:t>Kapitelüberschrift</a:t>
+            </a:r>
+          </a:p>
+        </p:txBody>
+      </p:sp>
+      <p:sp>
+        <p:nvSpPr>
+          <p:cNvPr id="119" name="Untertitel"/>
+          <p:cNvSpPr>
+            <a:spLocks noGrp="1"/>
+          </p:cNvSpPr>
+          <p:nvPr>
+            <p:ph type="body" sz="quarter" idx="13"/>
+          </p:nvPr>
+        </p:nvSpPr>
+        <p:spPr>
+          <a:xfrm>
+            <a:off x="527753" y="3819906"/>
+            <a:ext cx="8050476" cy="918972"/>
+          </a:xfrm>
+        </p:spPr>
+        <p:txBody>
+          <a:bodyPr lIns="36000" tIns="0" rIns="36000" bIns="0" anchor="t">
+            <a:normAutofit/>
+          </a:bodyPr>
+          <a:lstStyle>
+            <a:lvl1pPr marL="0" indent="0" algn="l">
+              <a:lnSpc>
+                <a:spcPct val="95000"/>
+              </a:lnSpc>
+              <a:spcBef>
+                <a:spcPts val="0"/>
+              </a:spcBef>
+              <a:buNone/>
+              <a:defRPr sz="3200" b="1">
+                <a:solidFill>
+                  <a:srgbClr val="FFFFFF"/>
+                </a:solidFill>
+              </a:defRPr>
+            </a:lvl1pPr>
+          </a:lstStyle>
+          <a:p>
+            <a:r>
+              <a:rPr lang="de-DE"/>
+              <a:t>Untertitel</a:t>
+            </a:r>
+          </a:p>
+        </p:txBody>
+      </p:sp>
     </p:spTree>
     <p:extLst>
       <p:ext uri="{BB962C8B-B14F-4D97-AF65-F5344CB8AC3E}">
@@ -591,7 +860,7 @@
       </p:grpSpPr>
       <p:sp>
         <p:nvSpPr>
-          <p:cNvPr id="2" name="Title 1"/>
+          <p:cNvPr id="120" name="Hauptheadline"/>
           <p:cNvSpPr>
             <a:spLocks noGrp="1"/>
           </p:cNvSpPr>
@@ -601,16 +870,21 @@
         </p:nvSpPr>
         <p:spPr>
           <a:xfrm>
-            <a:off x="489857" y="391885"/>
-            <a:ext cx="11212286" cy="783771"/>
-          </a:xfrm>
-        </p:spPr>
-        <p:txBody>
-          <a:bodyPr anchor="t"/>
+            <a:off x="512117" y="268239"/>
+            <a:ext cx="11122841" cy="402359"/>
+          </a:xfrm>
+        </p:spPr>
+        <p:txBody>
+          <a:bodyPr lIns="36000" tIns="0" rIns="36000" bIns="0" anchor="b">
+            <a:normAutofit/>
+          </a:bodyPr>
           <a:lstStyle>
             <a:lvl1pPr marL="0" indent="0" algn="l">
+              <a:spcBef>
+                <a:spcPts val="0"/>
+              </a:spcBef>
               <a:buNone/>
-              <a:defRPr sz="3200" b="1">
+              <a:defRPr sz="2800" b="1">
                 <a:solidFill>
                   <a:srgbClr val="001957"/>
                 </a:solidFill>
@@ -619,99 +893,78 @@
           </a:lstStyle>
           <a:p>
             <a:r>
-              <a:rPr lang="en-US" smtClean="0"/>
-              <a:t>Click to edit Master title style</a:t>
-            </a:r>
-            <a:endParaRPr lang="en-US"/>
-          </a:p>
-        </p:txBody>
-      </p:sp>
-      <p:sp>
-        <p:nvSpPr>
-          <p:cNvPr id="3" name="Content Placeholder 2"/>
+              <a:rPr lang="de-DE"/>
+              <a:t>Hauptheadline</a:t>
+            </a:r>
+          </a:p>
+        </p:txBody>
+      </p:sp>
+      <p:sp>
+        <p:nvSpPr>
+          <p:cNvPr id="121" name="Unterheadline"/>
           <p:cNvSpPr>
             <a:spLocks noGrp="1"/>
           </p:cNvSpPr>
           <p:nvPr>
-            <p:ph sz="half" idx="1"/>
+            <p:ph type="body" sz="quarter" idx="13"/>
           </p:nvPr>
         </p:nvSpPr>
         <p:spPr>
           <a:xfrm>
-            <a:off x="489857" y="1469571"/>
-            <a:ext cx="5361214" cy="3918856"/>
-          </a:xfrm>
-        </p:spPr>
-        <p:txBody>
-          <a:bodyPr/>
+            <a:off x="512117" y="679541"/>
+            <a:ext cx="11122841" cy="330829"/>
+          </a:xfrm>
+        </p:spPr>
+        <p:txBody>
+          <a:bodyPr lIns="36000" tIns="0" rIns="36000" bIns="0" anchor="t">
+            <a:normAutofit/>
+          </a:bodyPr>
           <a:lstStyle>
             <a:lvl1pPr marL="0" indent="0" algn="l">
+              <a:spcBef>
+                <a:spcPts val="0"/>
+              </a:spcBef>
               <a:buNone/>
-              <a:defRPr sz="1800" b="0">
-                <a:solidFill>
-                  <a:srgbClr val="001957"/>
+              <a:defRPr sz="2800" b="1">
+                <a:solidFill>
+                  <a:srgbClr val="EB6504"/>
                 </a:solidFill>
               </a:defRPr>
             </a:lvl1pPr>
           </a:lstStyle>
           <a:p>
-            <a:pPr lvl="0"/>
-            <a:r>
-              <a:rPr lang="en-US" smtClean="0"/>
-              <a:t>Click to edit Master text styles</a:t>
-            </a:r>
-          </a:p>
-          <a:p>
-            <a:pPr lvl="1"/>
-            <a:r>
-              <a:rPr lang="en-US" smtClean="0"/>
-              <a:t>Second level</a:t>
-            </a:r>
-          </a:p>
-          <a:p>
-            <a:pPr lvl="2"/>
-            <a:r>
-              <a:rPr lang="en-US" smtClean="0"/>
-              <a:t>Third level</a:t>
-            </a:r>
-          </a:p>
-          <a:p>
-            <a:pPr lvl="3"/>
-            <a:r>
-              <a:rPr lang="en-US" smtClean="0"/>
-              <a:t>Fourth level</a:t>
-            </a:r>
-          </a:p>
-          <a:p>
-            <a:pPr lvl="4"/>
-            <a:r>
-              <a:rPr lang="en-US" smtClean="0"/>
-              <a:t>Fifth level</a:t>
-            </a:r>
-            <a:endParaRPr lang="en-US"/>
-          </a:p>
-        </p:txBody>
-      </p:sp>
-      <p:sp>
-        <p:nvSpPr>
-          <p:cNvPr id="4" name="Content Placeholder 3"/>
+            <a:r>
+              <a:rPr lang="de-DE"/>
+              <a:t>Unterheadline</a:t>
+            </a:r>
+          </a:p>
+        </p:txBody>
+      </p:sp>
+      <p:sp>
+        <p:nvSpPr>
+          <p:cNvPr id="122" name="Inhalt links"/>
           <p:cNvSpPr>
             <a:spLocks noGrp="1"/>
           </p:cNvSpPr>
           <p:nvPr>
-            <p:ph sz="half" idx="2"/>
+            <p:ph idx="1"/>
           </p:nvPr>
         </p:nvSpPr>
         <p:spPr>
           <a:xfrm>
-            <a:off x="6340928" y="1469571"/>
-            <a:ext cx="5361214" cy="3918856"/>
-          </a:xfrm>
-        </p:spPr>
-        <p:txBody>
-          <a:bodyPr/>
+            <a:off x="512117" y="1341199"/>
+            <a:ext cx="5453606" cy="4738904"/>
+          </a:xfrm>
+        </p:spPr>
+        <p:txBody>
+          <a:bodyPr lIns="36000" tIns="0" rIns="36000" bIns="0" anchor="t">
+            <a:normAutofit/>
+          </a:bodyPr>
           <a:lstStyle>
             <a:lvl1pPr marL="0" indent="0" algn="l">
+              <a:spcBef>
+                <a:spcPts val="0"/>
+              </a:spcBef>
               <a:buNone/>
               <a:defRPr sz="1800" b="0">
                 <a:solidFill>
@@ -721,46 +974,129 @@
             </a:lvl1pPr>
           </a:lstStyle>
           <a:p>
-            <a:pPr lvl="0"/>
-            <a:r>
-              <a:rPr lang="en-US" smtClean="0"/>
-              <a:t>Click to edit Master text styles</a:t>
-            </a:r>
-          </a:p>
-          <a:p>
-            <a:pPr lvl="1"/>
-            <a:r>
-              <a:rPr lang="en-US" smtClean="0"/>
-              <a:t>Second level</a:t>
-            </a:r>
-          </a:p>
-          <a:p>
-            <a:pPr lvl="2"/>
-            <a:r>
-              <a:rPr lang="en-US" smtClean="0"/>
-              <a:t>Third level</a:t>
-            </a:r>
-          </a:p>
-          <a:p>
-            <a:pPr lvl="3"/>
-            <a:r>
-              <a:rPr lang="en-US" smtClean="0"/>
-              <a:t>Fourth level</a:t>
-            </a:r>
-          </a:p>
-          <a:p>
-            <a:pPr lvl="4"/>
-            <a:r>
-              <a:rPr lang="en-US" smtClean="0"/>
-              <a:t>Fifth level</a:t>
-            </a:r>
-            <a:endParaRPr lang="en-US"/>
+            <a:r>
+              <a:rPr lang="de-DE"/>
+              <a:t>Inhalt</a:t>
+            </a:r>
+          </a:p>
+        </p:txBody>
+      </p:sp>
+      <p:sp>
+        <p:nvSpPr>
+          <p:cNvPr id="123" name="Inhalt rechts"/>
+          <p:cNvSpPr>
+            <a:spLocks noGrp="1"/>
+          </p:cNvSpPr>
+          <p:nvPr>
+            <p:ph idx="2"/>
+          </p:nvPr>
+        </p:nvSpPr>
+        <p:spPr>
+          <a:xfrm>
+            <a:off x="6181352" y="1341199"/>
+            <a:ext cx="5453606" cy="4738904"/>
+          </a:xfrm>
+        </p:spPr>
+        <p:txBody>
+          <a:bodyPr lIns="36000" tIns="0" rIns="36000" bIns="0" anchor="t">
+            <a:normAutofit/>
+          </a:bodyPr>
+          <a:lstStyle>
+            <a:lvl1pPr marL="0" indent="0" algn="l">
+              <a:spcBef>
+                <a:spcPts val="0"/>
+              </a:spcBef>
+              <a:buNone/>
+              <a:defRPr sz="1800" b="0">
+                <a:solidFill>
+                  <a:srgbClr val="001957"/>
+                </a:solidFill>
+              </a:defRPr>
+            </a:lvl1pPr>
+          </a:lstStyle>
+          <a:p>
+            <a:r>
+              <a:rPr lang="de-DE"/>
+              <a:t>Inhalt</a:t>
+            </a:r>
+          </a:p>
+        </p:txBody>
+      </p:sp>
+      <p:sp>
+        <p:nvSpPr>
+          <p:cNvPr id="125" name="Foliennummer"/>
+          <p:cNvSpPr txBox="1"/>
+          <p:nvPr userDrawn="1"/>
+        </p:nvSpPr>
+        <p:spPr>
+          <a:xfrm>
+            <a:off x="521102" y="6209919"/>
+            <a:ext cx="359380" cy="219456"/>
+          </a:xfrm>
+          <a:prstGeom prst="rect">
+            <a:avLst/>
+          </a:prstGeom>
+          <a:noFill/>
+        </p:spPr>
+        <p:txBody>
+          <a:bodyPr wrap="square" lIns="0" tIns="0" rIns="0" bIns="0" anchor="t"/>
+          <a:lstStyle/>
+          <a:p>
+            <a:fld id="{B6F15528-21DE-4FAA-801E-634DDDAF4B124}" type="slidenum">
+              <a:rPr lang="de-DE" sz="1100" b="1">
+                <a:solidFill>
+                  <a:srgbClr val="001957"/>
+                </a:solidFill>
+              </a:rPr>
+              <a:t>‹#›</a:t>
+            </a:fld>
+          </a:p>
+        </p:txBody>
+      </p:sp>
+      <p:sp>
+        <p:nvSpPr>
+          <p:cNvPr id="127" name="Titel der Präsentation"/>
+          <p:cNvSpPr txBox="1"/>
+          <p:nvPr userDrawn="1"/>
+        </p:nvSpPr>
+        <p:spPr>
+          <a:xfrm>
+            <a:off x="997282" y="6209919"/>
+            <a:ext cx="6289167" cy="360045"/>
+          </a:xfrm>
+          <a:prstGeom prst="rect">
+            <a:avLst/>
+          </a:prstGeom>
+          <a:noFill/>
+        </p:spPr>
+        <p:txBody>
+          <a:bodyPr wrap="square" lIns="0" tIns="0" rIns="0" bIns="0" anchor="t"/>
+          <a:lstStyle/>
+          <a:p>
+            <a:r>
+              <a:rPr lang="de-DE" sz="1100" b="1">
+                <a:solidFill>
+                  <a:srgbClr val="001957"/>
+                </a:solidFill>
+              </a:rPr>
+              <a:t>Titel der Präsentation</a:t>
+            </a:r>
+          </a:p>
+          <a:p>
+            <a:fld id="{B6F15528-21DE-4FAA-801E-634DDDAF4B126}" type="datetime1">
+              <a:rPr lang="de-DE" sz="1100" b="0">
+                <a:solidFill>
+                  <a:srgbClr val="001957"/>
+                </a:solidFill>
+              </a:rPr>
+              <a:t>01.01.2026</a:t>
+            </a:fld>
           </a:p>
         </p:txBody>
       </p:sp>
       <p:pic>
         <p:nvPicPr>
-          <p:cNvPr id="105" name="Logo" descr="R+V"/>
+          <p:cNvPr id="128" name="Logo" descr="R+V Logo"/>
           <p:cNvPicPr>
             <a:picLocks noChangeAspect="1"/>
           </p:cNvPicPr>
@@ -774,36 +1110,14 @@
         </p:blipFill>
         <p:spPr>
           <a:xfrm>
-            <a:off x="10526486" y="5774864"/>
-            <a:ext cx="1175656" cy="789220"/>
+            <a:off x="10800097" y="6080996"/>
+            <a:ext cx="1040806" cy="698695"/>
           </a:xfrm>
           <a:prstGeom prst="rect">
             <a:avLst/>
           </a:prstGeom>
         </p:spPr>
       </p:pic>
-      <p:sp>
-        <p:nvSpPr>
-          <p:cNvPr id="106" name="Akzent"/>
-          <p:cNvSpPr/>
-          <p:nvPr userDrawn="1"/>
-        </p:nvSpPr>
-        <p:spPr>
-          <a:xfrm>
-            <a:off x="0" y="0"/>
-            <a:ext cx="171449" cy="6858000"/>
-          </a:xfrm>
-          <a:prstGeom prst="rect">
-            <a:avLst/>
-          </a:prstGeom>
-          <a:solidFill>
-            <a:srgbClr val="EB6504"/>
-          </a:solidFill>
-          <a:ln>
-            <a:noFill/>
-          </a:ln>
-        </p:spPr>
-      </p:sp>
     </p:spTree>
     <p:extLst>
       <p:ext uri="{BB962C8B-B14F-4D97-AF65-F5344CB8AC3E}">
@@ -844,7 +1158,7 @@
       </p:grpSpPr>
       <p:sp>
         <p:nvSpPr>
-          <p:cNvPr id="2" name="Title 1"/>
+          <p:cNvPr id="129" name="Hauptheadline"/>
           <p:cNvSpPr>
             <a:spLocks noGrp="1"/>
           </p:cNvSpPr>
@@ -854,16 +1168,21 @@
         </p:nvSpPr>
         <p:spPr>
           <a:xfrm>
-            <a:off x="489857" y="391885"/>
-            <a:ext cx="11212286" cy="783771"/>
-          </a:xfrm>
-        </p:spPr>
-        <p:txBody>
-          <a:bodyPr anchor="t"/>
+            <a:off x="512117" y="268239"/>
+            <a:ext cx="11122841" cy="402359"/>
+          </a:xfrm>
+        </p:spPr>
+        <p:txBody>
+          <a:bodyPr lIns="36000" tIns="0" rIns="36000" bIns="0" anchor="b">
+            <a:normAutofit/>
+          </a:bodyPr>
           <a:lstStyle>
             <a:lvl1pPr marL="0" indent="0" algn="l">
+              <a:spcBef>
+                <a:spcPts val="0"/>
+              </a:spcBef>
               <a:buNone/>
-              <a:defRPr sz="3200" b="1">
+              <a:defRPr sz="2800" b="1">
                 <a:solidFill>
                   <a:srgbClr val="001957"/>
                 </a:solidFill>
@@ -872,16 +1191,128 @@
           </a:lstStyle>
           <a:p>
             <a:r>
-              <a:rPr lang="en-US" smtClean="0"/>
-              <a:t>Click to edit Master title style</a:t>
-            </a:r>
-            <a:endParaRPr lang="en-US"/>
+              <a:rPr lang="de-DE"/>
+              <a:t>Hauptheadline</a:t>
+            </a:r>
+          </a:p>
+        </p:txBody>
+      </p:sp>
+      <p:sp>
+        <p:nvSpPr>
+          <p:cNvPr id="130" name="Unterheadline"/>
+          <p:cNvSpPr>
+            <a:spLocks noGrp="1"/>
+          </p:cNvSpPr>
+          <p:nvPr>
+            <p:ph type="body" sz="quarter" idx="13"/>
+          </p:nvPr>
+        </p:nvSpPr>
+        <p:spPr>
+          <a:xfrm>
+            <a:off x="512117" y="679541"/>
+            <a:ext cx="11122841" cy="330829"/>
+          </a:xfrm>
+        </p:spPr>
+        <p:txBody>
+          <a:bodyPr lIns="36000" tIns="0" rIns="36000" bIns="0" anchor="t">
+            <a:normAutofit/>
+          </a:bodyPr>
+          <a:lstStyle>
+            <a:lvl1pPr marL="0" indent="0" algn="l">
+              <a:spcBef>
+                <a:spcPts val="0"/>
+              </a:spcBef>
+              <a:buNone/>
+              <a:defRPr sz="2800" b="1">
+                <a:solidFill>
+                  <a:srgbClr val="EB6504"/>
+                </a:solidFill>
+              </a:defRPr>
+            </a:lvl1pPr>
+          </a:lstStyle>
+          <a:p>
+            <a:r>
+              <a:rPr lang="de-DE"/>
+              <a:t>Unterheadline</a:t>
+            </a:r>
+          </a:p>
+        </p:txBody>
+      </p:sp>
+      <p:sp>
+        <p:nvSpPr>
+          <p:cNvPr id="132" name="Foliennummer"/>
+          <p:cNvSpPr txBox="1"/>
+          <p:nvPr userDrawn="1"/>
+        </p:nvSpPr>
+        <p:spPr>
+          <a:xfrm>
+            <a:off x="521102" y="6209919"/>
+            <a:ext cx="359380" cy="219456"/>
+          </a:xfrm>
+          <a:prstGeom prst="rect">
+            <a:avLst/>
+          </a:prstGeom>
+          <a:noFill/>
+        </p:spPr>
+        <p:txBody>
+          <a:bodyPr wrap="square" lIns="0" tIns="0" rIns="0" bIns="0" anchor="t"/>
+          <a:lstStyle/>
+          <a:p>
+            <a:fld id="{B6F15528-21DE-4FAA-801E-634DDDAF4B131}" type="slidenum">
+              <a:rPr lang="de-DE" sz="1100" b="1">
+                <a:solidFill>
+                  <a:srgbClr val="001957"/>
+                </a:solidFill>
+              </a:rPr>
+              <a:t>‹#›</a:t>
+            </a:fld>
+          </a:p>
+        </p:txBody>
+      </p:sp>
+      <p:sp>
+        <p:nvSpPr>
+          <p:cNvPr id="134" name="Titel der Präsentation"/>
+          <p:cNvSpPr txBox="1"/>
+          <p:nvPr userDrawn="1"/>
+        </p:nvSpPr>
+        <p:spPr>
+          <a:xfrm>
+            <a:off x="997282" y="6209919"/>
+            <a:ext cx="6289167" cy="360045"/>
+          </a:xfrm>
+          <a:prstGeom prst="rect">
+            <a:avLst/>
+          </a:prstGeom>
+          <a:noFill/>
+        </p:spPr>
+        <p:txBody>
+          <a:bodyPr wrap="square" lIns="0" tIns="0" rIns="0" bIns="0" anchor="t"/>
+          <a:lstStyle/>
+          <a:p>
+            <a:r>
+              <a:rPr lang="de-DE" sz="1100" b="1">
+                <a:solidFill>
+                  <a:srgbClr val="001957"/>
+                </a:solidFill>
+              </a:rPr>
+              <a:t>Titel der Präsentation</a:t>
+            </a:r>
+          </a:p>
+          <a:p>
+            <a:fld id="{B6F15528-21DE-4FAA-801E-634DDDAF4B133}" type="datetime1">
+              <a:rPr lang="de-DE" sz="1100" b="0">
+                <a:solidFill>
+                  <a:srgbClr val="001957"/>
+                </a:solidFill>
+              </a:rPr>
+              <a:t>01.01.2026</a:t>
+            </a:fld>
           </a:p>
         </p:txBody>
       </p:sp>
       <p:pic>
         <p:nvPicPr>
-          <p:cNvPr id="107" name="Logo" descr="R+V"/>
+          <p:cNvPr id="135" name="Logo" descr="R+V Logo"/>
           <p:cNvPicPr>
             <a:picLocks noChangeAspect="1"/>
           </p:cNvPicPr>
@@ -895,36 +1326,14 @@
         </p:blipFill>
         <p:spPr>
           <a:xfrm>
-            <a:off x="10526486" y="5774864"/>
-            <a:ext cx="1175656" cy="789220"/>
+            <a:off x="10800097" y="6080996"/>
+            <a:ext cx="1040806" cy="698695"/>
           </a:xfrm>
           <a:prstGeom prst="rect">
             <a:avLst/>
           </a:prstGeom>
         </p:spPr>
       </p:pic>
-      <p:sp>
-        <p:nvSpPr>
-          <p:cNvPr id="108" name="Akzent"/>
-          <p:cNvSpPr/>
-          <p:nvPr userDrawn="1"/>
-        </p:nvSpPr>
-        <p:spPr>
-          <a:xfrm>
-            <a:off x="0" y="0"/>
-            <a:ext cx="171449" cy="6858000"/>
-          </a:xfrm>
-          <a:prstGeom prst="rect">
-            <a:avLst/>
-          </a:prstGeom>
-          <a:solidFill>
-            <a:srgbClr val="EB6504"/>
-          </a:solidFill>
-          <a:ln>
-            <a:noFill/>
-          </a:ln>
-        </p:spPr>
-      </p:sp>
     </p:spTree>
     <p:extLst>
       <p:ext uri="{BB962C8B-B14F-4D97-AF65-F5344CB8AC3E}">

</xml_diff>

<commit_message>
GFG-Logo auf der PPTX-Startseite, GFG-Assets, Regel: ohne gelieferte Bilder keine Bilder erstellen
Co-Authored-By: Claude Sonnet 5.5 <noreply@anthropic.com>
Claude-Session: https://claude.ai/code/session_01LZiKgyJNCoBGmUkDiAUEHD
</commit_message>
<xml_diff>
--- a/templates/ruv.pptx
+++ b/templates/ruv.pptx
@@ -341,78 +341,30 @@
           </a:p>
         </p:txBody>
       </p:sp>
-      <p:sp>
-        <p:nvSpPr>
-          <p:cNvPr id="107" name="Die Versicherung in der"/>
-          <p:cNvSpPr txBox="1"/>
+      <p:pic>
+        <p:nvPicPr>
+          <p:cNvPr id="107" name="Logo" descr="R+V Logo"/>
+          <p:cNvPicPr>
+            <a:picLocks noChangeAspect="1"/>
+          </p:cNvPicPr>
           <p:nvPr userDrawn="1"/>
-        </p:nvSpPr>
-        <p:spPr>
-          <a:xfrm>
-            <a:off x="536698" y="5901309"/>
-            <a:ext cx="2683492" cy="205740"/>
+        </p:nvPicPr>
+        <p:blipFill>
+          <a:blip r:embed="rId3"/>
+          <a:stretch>
+            <a:fillRect/>
+          </a:stretch>
+        </p:blipFill>
+        <p:spPr>
+          <a:xfrm>
+            <a:off x="66132" y="5443063"/>
+            <a:ext cx="2630217" cy="1372072"/>
           </a:xfrm>
           <a:prstGeom prst="rect">
             <a:avLst/>
           </a:prstGeom>
-          <a:noFill/>
-        </p:spPr>
-        <p:txBody>
-          <a:bodyPr wrap="square" lIns="0" tIns="0" rIns="0" bIns="0" anchor="t"/>
-          <a:lstStyle/>
-          <a:p>
-            <a:r>
-              <a:rPr lang="de-DE" sz="1100" b="1">
-                <a:solidFill>
-                  <a:srgbClr val="FFFFFF"/>
-                </a:solidFill>
-              </a:rPr>
-              <a:t>Die Versicherung in der</a:t>
-            </a:r>
-          </a:p>
-        </p:txBody>
-      </p:sp>
-      <p:sp>
-        <p:nvSpPr>
-          <p:cNvPr id="108" name="Logo Genossenschaftliche Finanzgruppe (Platzhalter)"/>
-          <p:cNvSpPr txBox="1"/>
-          <p:nvPr userDrawn="1"/>
-        </p:nvSpPr>
-        <p:spPr>
-          <a:xfrm>
-            <a:off x="536698" y="6137910"/>
-            <a:ext cx="2683492" cy="274320"/>
-          </a:xfrm>
-          <a:prstGeom prst="rect">
-            <a:avLst/>
-          </a:prstGeom>
-          <a:noFill/>
-        </p:spPr>
-        <p:txBody>
-          <a:bodyPr wrap="square" lIns="0" tIns="0" rIns="0" bIns="0" anchor="t"/>
-          <a:lstStyle/>
-          <a:p>
-            <a:r>
-              <a:rPr lang="de-DE" sz="800" b="0">
-                <a:solidFill>
-                  <a:srgbClr val="FFFFFF"/>
-                </a:solidFill>
-              </a:rPr>
-              <a:t>Genossenschaftliche Finanzgruppe</a:t>
-            </a:r>
-          </a:p>
-          <a:p>
-            <a:r>
-              <a:rPr lang="de-DE" sz="800" b="0">
-                <a:solidFill>
-                  <a:srgbClr val="FFFFFF"/>
-                </a:solidFill>
-              </a:rPr>
-              <a:t>Volksbanken Raiffeisenbanken</a:t>
-            </a:r>
-          </a:p>
-        </p:txBody>
-      </p:sp>
+        </p:spPr>
+      </p:pic>
     </p:spTree>
     <p:extLst>
       <p:ext uri="{BB962C8B-B14F-4D97-AF65-F5344CB8AC3E}">
@@ -453,7 +405,7 @@
       </p:grpSpPr>
       <p:sp>
         <p:nvSpPr>
-          <p:cNvPr id="109" name="Hauptheadline"/>
+          <p:cNvPr id="108" name="Hauptheadline"/>
           <p:cNvSpPr>
             <a:spLocks noGrp="1"/>
           </p:cNvSpPr>
@@ -494,7 +446,7 @@
       </p:sp>
       <p:sp>
         <p:nvSpPr>
-          <p:cNvPr id="110" name="Unterheadline"/>
+          <p:cNvPr id="109" name="Unterheadline"/>
           <p:cNvSpPr>
             <a:spLocks noGrp="1"/>
           </p:cNvSpPr>
@@ -535,7 +487,7 @@
       </p:sp>
       <p:sp>
         <p:nvSpPr>
-          <p:cNvPr id="111" name="Inhalt"/>
+          <p:cNvPr id="110" name="Inhalt"/>
           <p:cNvSpPr>
             <a:spLocks noGrp="1"/>
           </p:cNvSpPr>
@@ -576,7 +528,7 @@
       </p:sp>
       <p:sp>
         <p:nvSpPr>
-          <p:cNvPr id="113" name="Foliennummer"/>
+          <p:cNvPr id="112" name="Foliennummer"/>
           <p:cNvSpPr txBox="1"/>
           <p:nvPr userDrawn="1"/>
         </p:nvSpPr>
@@ -594,7 +546,7 @@
           <a:bodyPr wrap="square" lIns="0" tIns="0" rIns="0" bIns="0" anchor="t"/>
           <a:lstStyle/>
           <a:p>
-            <a:fld id="{B6F15528-21DE-4FAA-801E-634DDDAF4B112}" type="slidenum">
+            <a:fld id="{B6F15528-21DE-4FAA-801E-634DDDAF4B111}" type="slidenum">
               <a:rPr lang="de-DE" sz="1100" b="1">
                 <a:solidFill>
                   <a:srgbClr val="001957"/>
@@ -607,7 +559,7 @@
       </p:sp>
       <p:sp>
         <p:nvSpPr>
-          <p:cNvPr id="115" name="Titel der Präsentation"/>
+          <p:cNvPr id="114" name="Titel der Präsentation"/>
           <p:cNvSpPr txBox="1"/>
           <p:nvPr userDrawn="1"/>
         </p:nvSpPr>
@@ -635,7 +587,7 @@
             </a:r>
           </a:p>
           <a:p>
-            <a:fld id="{B6F15528-21DE-4FAA-801E-634DDDAF4B114}" type="datetime1">
+            <a:fld id="{B6F15528-21DE-4FAA-801E-634DDDAF4B113}" type="datetime1">
               <a:rPr lang="de-DE" sz="1100" b="0">
                 <a:solidFill>
                   <a:srgbClr val="001957"/>
@@ -648,7 +600,7 @@
       </p:sp>
       <p:pic>
         <p:nvPicPr>
-          <p:cNvPr id="116" name="Logo" descr="R+V Logo"/>
+          <p:cNvPr id="115" name="Logo" descr="R+V Logo"/>
           <p:cNvPicPr>
             <a:picLocks noChangeAspect="1"/>
           </p:cNvPicPr>
@@ -710,7 +662,7 @@
       </p:grpSpPr>
       <p:pic>
         <p:nvPicPr>
-          <p:cNvPr id="117" name="Logo" descr="R+V Logo"/>
+          <p:cNvPr id="116" name="Logo" descr="R+V Logo"/>
           <p:cNvPicPr>
             <a:picLocks noChangeAspect="1"/>
           </p:cNvPicPr>
@@ -734,7 +686,7 @@
       </p:pic>
       <p:sp>
         <p:nvSpPr>
-          <p:cNvPr id="118" name="Haupttitel"/>
+          <p:cNvPr id="117" name="Haupttitel"/>
           <p:cNvSpPr>
             <a:spLocks noGrp="1"/>
           </p:cNvSpPr>
@@ -778,7 +730,7 @@
       </p:sp>
       <p:sp>
         <p:nvSpPr>
-          <p:cNvPr id="119" name="Untertitel"/>
+          <p:cNvPr id="118" name="Untertitel"/>
           <p:cNvSpPr>
             <a:spLocks noGrp="1"/>
           </p:cNvSpPr>
@@ -860,7 +812,7 @@
       </p:grpSpPr>
       <p:sp>
         <p:nvSpPr>
-          <p:cNvPr id="120" name="Hauptheadline"/>
+          <p:cNvPr id="119" name="Hauptheadline"/>
           <p:cNvSpPr>
             <a:spLocks noGrp="1"/>
           </p:cNvSpPr>
@@ -901,7 +853,7 @@
       </p:sp>
       <p:sp>
         <p:nvSpPr>
-          <p:cNvPr id="121" name="Unterheadline"/>
+          <p:cNvPr id="120" name="Unterheadline"/>
           <p:cNvSpPr>
             <a:spLocks noGrp="1"/>
           </p:cNvSpPr>
@@ -942,7 +894,7 @@
       </p:sp>
       <p:sp>
         <p:nvSpPr>
-          <p:cNvPr id="122" name="Inhalt links"/>
+          <p:cNvPr id="121" name="Inhalt links"/>
           <p:cNvSpPr>
             <a:spLocks noGrp="1"/>
           </p:cNvSpPr>
@@ -983,7 +935,7 @@
       </p:sp>
       <p:sp>
         <p:nvSpPr>
-          <p:cNvPr id="123" name="Inhalt rechts"/>
+          <p:cNvPr id="122" name="Inhalt rechts"/>
           <p:cNvSpPr>
             <a:spLocks noGrp="1"/>
           </p:cNvSpPr>
@@ -1024,7 +976,7 @@
       </p:sp>
       <p:sp>
         <p:nvSpPr>
-          <p:cNvPr id="125" name="Foliennummer"/>
+          <p:cNvPr id="124" name="Foliennummer"/>
           <p:cNvSpPr txBox="1"/>
           <p:nvPr userDrawn="1"/>
         </p:nvSpPr>
@@ -1042,7 +994,7 @@
           <a:bodyPr wrap="square" lIns="0" tIns="0" rIns="0" bIns="0" anchor="t"/>
           <a:lstStyle/>
           <a:p>
-            <a:fld id="{B6F15528-21DE-4FAA-801E-634DDDAF4B124}" type="slidenum">
+            <a:fld id="{B6F15528-21DE-4FAA-801E-634DDDAF4B123}" type="slidenum">
               <a:rPr lang="de-DE" sz="1100" b="1">
                 <a:solidFill>
                   <a:srgbClr val="001957"/>
@@ -1055,7 +1007,7 @@
       </p:sp>
       <p:sp>
         <p:nvSpPr>
-          <p:cNvPr id="127" name="Titel der Präsentation"/>
+          <p:cNvPr id="126" name="Titel der Präsentation"/>
           <p:cNvSpPr txBox="1"/>
           <p:nvPr userDrawn="1"/>
         </p:nvSpPr>
@@ -1083,7 +1035,7 @@
             </a:r>
           </a:p>
           <a:p>
-            <a:fld id="{B6F15528-21DE-4FAA-801E-634DDDAF4B126}" type="datetime1">
+            <a:fld id="{B6F15528-21DE-4FAA-801E-634DDDAF4B125}" type="datetime1">
               <a:rPr lang="de-DE" sz="1100" b="0">
                 <a:solidFill>
                   <a:srgbClr val="001957"/>
@@ -1096,7 +1048,7 @@
       </p:sp>
       <p:pic>
         <p:nvPicPr>
-          <p:cNvPr id="128" name="Logo" descr="R+V Logo"/>
+          <p:cNvPr id="127" name="Logo" descr="R+V Logo"/>
           <p:cNvPicPr>
             <a:picLocks noChangeAspect="1"/>
           </p:cNvPicPr>
@@ -1158,7 +1110,7 @@
       </p:grpSpPr>
       <p:sp>
         <p:nvSpPr>
-          <p:cNvPr id="129" name="Hauptheadline"/>
+          <p:cNvPr id="128" name="Hauptheadline"/>
           <p:cNvSpPr>
             <a:spLocks noGrp="1"/>
           </p:cNvSpPr>
@@ -1199,7 +1151,7 @@
       </p:sp>
       <p:sp>
         <p:nvSpPr>
-          <p:cNvPr id="130" name="Unterheadline"/>
+          <p:cNvPr id="129" name="Unterheadline"/>
           <p:cNvSpPr>
             <a:spLocks noGrp="1"/>
           </p:cNvSpPr>
@@ -1240,7 +1192,7 @@
       </p:sp>
       <p:sp>
         <p:nvSpPr>
-          <p:cNvPr id="132" name="Foliennummer"/>
+          <p:cNvPr id="131" name="Foliennummer"/>
           <p:cNvSpPr txBox="1"/>
           <p:nvPr userDrawn="1"/>
         </p:nvSpPr>
@@ -1258,7 +1210,7 @@
           <a:bodyPr wrap="square" lIns="0" tIns="0" rIns="0" bIns="0" anchor="t"/>
           <a:lstStyle/>
           <a:p>
-            <a:fld id="{B6F15528-21DE-4FAA-801E-634DDDAF4B131}" type="slidenum">
+            <a:fld id="{B6F15528-21DE-4FAA-801E-634DDDAF4B130}" type="slidenum">
               <a:rPr lang="de-DE" sz="1100" b="1">
                 <a:solidFill>
                   <a:srgbClr val="001957"/>
@@ -1271,7 +1223,7 @@
       </p:sp>
       <p:sp>
         <p:nvSpPr>
-          <p:cNvPr id="134" name="Titel der Präsentation"/>
+          <p:cNvPr id="133" name="Titel der Präsentation"/>
           <p:cNvSpPr txBox="1"/>
           <p:nvPr userDrawn="1"/>
         </p:nvSpPr>
@@ -1299,7 +1251,7 @@
             </a:r>
           </a:p>
           <a:p>
-            <a:fld id="{B6F15528-21DE-4FAA-801E-634DDDAF4B133}" type="datetime1">
+            <a:fld id="{B6F15528-21DE-4FAA-801E-634DDDAF4B132}" type="datetime1">
               <a:rPr lang="de-DE" sz="1100" b="0">
                 <a:solidFill>
                   <a:srgbClr val="001957"/>
@@ -1312,7 +1264,7 @@
       </p:sp>
       <p:pic>
         <p:nvPicPr>
-          <p:cNvPr id="135" name="Logo" descr="R+V Logo"/>
+          <p:cNvPr id="134" name="Logo" descr="R+V Logo"/>
           <p:cNvPicPr>
             <a:picLocks noChangeAspect="1"/>
           </p:cNvPicPr>

</xml_diff>

<commit_message>
PPTX-Vorlage: gültige GUIDs für Datumsfelder
Die Datumsfelder in der Fußzeile hatten 13 statt 12 Hexziffern im letzten GUID-Block.
PowerPoint meldet die Datei dann als beschädigt und verwirft beim Reparieren die Layouts.

Co-Authored-By: Claude Opus 5.5 (1M context) <noreply@anthropic.com>
Claude-Session: https://claude.ai/code/session_01M4rEXzL8UEswz3hhtHJS6u
</commit_message>
<xml_diff>
--- a/templates/ruv.pptx
+++ b/templates/ruv.pptx
@@ -528,7 +528,7 @@
       </p:sp>
       <p:sp>
         <p:nvSpPr>
-          <p:cNvPr id="112" name="Foliennummer"/>
+          <p:cNvPr id="111" name="Foliennummer"/>
           <p:cNvSpPr txBox="1"/>
           <p:nvPr userDrawn="1"/>
         </p:nvSpPr>
@@ -546,7 +546,7 @@
           <a:bodyPr wrap="square" lIns="0" tIns="0" rIns="0" bIns="0" anchor="t"/>
           <a:lstStyle/>
           <a:p>
-            <a:fld id="{B6F15528-21DE-4FAA-801E-634DDDAF4B111}" type="slidenum">
+            <a:fld id="{8E0C8BB0-4148-4D49-B4EA-77B9D8D7DE0D}" type="slidenum">
               <a:rPr lang="de-DE" sz="1100" b="1">
                 <a:solidFill>
                   <a:srgbClr val="001957"/>
@@ -559,7 +559,7 @@
       </p:sp>
       <p:sp>
         <p:nvSpPr>
-          <p:cNvPr id="114" name="Titel der Präsentation"/>
+          <p:cNvPr id="112" name="Titel der Präsentation"/>
           <p:cNvSpPr txBox="1"/>
           <p:nvPr userDrawn="1"/>
         </p:nvSpPr>
@@ -587,7 +587,7 @@
             </a:r>
           </a:p>
           <a:p>
-            <a:fld id="{B6F15528-21DE-4FAA-801E-634DDDAF4B113}" type="datetime1">
+            <a:fld id="{70727C23-D070-4A6E-A4B8-0208138AD74C}" type="datetime1">
               <a:rPr lang="de-DE" sz="1100" b="0">
                 <a:solidFill>
                   <a:srgbClr val="001957"/>
@@ -600,7 +600,7 @@
       </p:sp>
       <p:pic>
         <p:nvPicPr>
-          <p:cNvPr id="115" name="Logo" descr="R+V Logo"/>
+          <p:cNvPr id="113" name="Logo" descr="R+V Logo"/>
           <p:cNvPicPr>
             <a:picLocks noChangeAspect="1"/>
           </p:cNvPicPr>
@@ -662,7 +662,7 @@
       </p:grpSpPr>
       <p:pic>
         <p:nvPicPr>
-          <p:cNvPr id="116" name="Logo" descr="R+V Logo"/>
+          <p:cNvPr id="114" name="Logo" descr="R+V Logo"/>
           <p:cNvPicPr>
             <a:picLocks noChangeAspect="1"/>
           </p:cNvPicPr>
@@ -686,7 +686,7 @@
       </p:pic>
       <p:sp>
         <p:nvSpPr>
-          <p:cNvPr id="117" name="Haupttitel"/>
+          <p:cNvPr id="115" name="Haupttitel"/>
           <p:cNvSpPr>
             <a:spLocks noGrp="1"/>
           </p:cNvSpPr>
@@ -730,7 +730,7 @@
       </p:sp>
       <p:sp>
         <p:nvSpPr>
-          <p:cNvPr id="118" name="Untertitel"/>
+          <p:cNvPr id="116" name="Untertitel"/>
           <p:cNvSpPr>
             <a:spLocks noGrp="1"/>
           </p:cNvSpPr>
@@ -812,7 +812,7 @@
       </p:grpSpPr>
       <p:sp>
         <p:nvSpPr>
-          <p:cNvPr id="119" name="Hauptheadline"/>
+          <p:cNvPr id="117" name="Hauptheadline"/>
           <p:cNvSpPr>
             <a:spLocks noGrp="1"/>
           </p:cNvSpPr>
@@ -853,7 +853,7 @@
       </p:sp>
       <p:sp>
         <p:nvSpPr>
-          <p:cNvPr id="120" name="Unterheadline"/>
+          <p:cNvPr id="118" name="Unterheadline"/>
           <p:cNvSpPr>
             <a:spLocks noGrp="1"/>
           </p:cNvSpPr>
@@ -894,7 +894,7 @@
       </p:sp>
       <p:sp>
         <p:nvSpPr>
-          <p:cNvPr id="121" name="Inhalt links"/>
+          <p:cNvPr id="119" name="Inhalt links"/>
           <p:cNvSpPr>
             <a:spLocks noGrp="1"/>
           </p:cNvSpPr>
@@ -935,7 +935,7 @@
       </p:sp>
       <p:sp>
         <p:nvSpPr>
-          <p:cNvPr id="122" name="Inhalt rechts"/>
+          <p:cNvPr id="120" name="Inhalt rechts"/>
           <p:cNvSpPr>
             <a:spLocks noGrp="1"/>
           </p:cNvSpPr>
@@ -976,7 +976,7 @@
       </p:sp>
       <p:sp>
         <p:nvSpPr>
-          <p:cNvPr id="124" name="Foliennummer"/>
+          <p:cNvPr id="121" name="Foliennummer"/>
           <p:cNvSpPr txBox="1"/>
           <p:nvPr userDrawn="1"/>
         </p:nvSpPr>
@@ -994,7 +994,7 @@
           <a:bodyPr wrap="square" lIns="0" tIns="0" rIns="0" bIns="0" anchor="t"/>
           <a:lstStyle/>
           <a:p>
-            <a:fld id="{B6F15528-21DE-4FAA-801E-634DDDAF4B123}" type="slidenum">
+            <a:fld id="{2B69EE39-67D0-4DEE-B0CB-E81B90525783}" type="slidenum">
               <a:rPr lang="de-DE" sz="1100" b="1">
                 <a:solidFill>
                   <a:srgbClr val="001957"/>
@@ -1007,7 +1007,7 @@
       </p:sp>
       <p:sp>
         <p:nvSpPr>
-          <p:cNvPr id="126" name="Titel der Präsentation"/>
+          <p:cNvPr id="122" name="Titel der Präsentation"/>
           <p:cNvSpPr txBox="1"/>
           <p:nvPr userDrawn="1"/>
         </p:nvSpPr>
@@ -1035,7 +1035,7 @@
             </a:r>
           </a:p>
           <a:p>
-            <a:fld id="{B6F15528-21DE-4FAA-801E-634DDDAF4B125}" type="datetime1">
+            <a:fld id="{C7388E26-8403-4CAF-A845-85D84EF990BD}" type="datetime1">
               <a:rPr lang="de-DE" sz="1100" b="0">
                 <a:solidFill>
                   <a:srgbClr val="001957"/>
@@ -1048,7 +1048,7 @@
       </p:sp>
       <p:pic>
         <p:nvPicPr>
-          <p:cNvPr id="127" name="Logo" descr="R+V Logo"/>
+          <p:cNvPr id="123" name="Logo" descr="R+V Logo"/>
           <p:cNvPicPr>
             <a:picLocks noChangeAspect="1"/>
           </p:cNvPicPr>
@@ -1110,7 +1110,7 @@
       </p:grpSpPr>
       <p:sp>
         <p:nvSpPr>
-          <p:cNvPr id="128" name="Hauptheadline"/>
+          <p:cNvPr id="124" name="Hauptheadline"/>
           <p:cNvSpPr>
             <a:spLocks noGrp="1"/>
           </p:cNvSpPr>
@@ -1151,7 +1151,7 @@
       </p:sp>
       <p:sp>
         <p:nvSpPr>
-          <p:cNvPr id="129" name="Unterheadline"/>
+          <p:cNvPr id="125" name="Unterheadline"/>
           <p:cNvSpPr>
             <a:spLocks noGrp="1"/>
           </p:cNvSpPr>
@@ -1192,7 +1192,7 @@
       </p:sp>
       <p:sp>
         <p:nvSpPr>
-          <p:cNvPr id="131" name="Foliennummer"/>
+          <p:cNvPr id="126" name="Foliennummer"/>
           <p:cNvSpPr txBox="1"/>
           <p:nvPr userDrawn="1"/>
         </p:nvSpPr>
@@ -1210,7 +1210,7 @@
           <a:bodyPr wrap="square" lIns="0" tIns="0" rIns="0" bIns="0" anchor="t"/>
           <a:lstStyle/>
           <a:p>
-            <a:fld id="{B6F15528-21DE-4FAA-801E-634DDDAF4B130}" type="slidenum">
+            <a:fld id="{A3C1BBF4-CCF8-4197-ACDF-52B3CC889267}" type="slidenum">
               <a:rPr lang="de-DE" sz="1100" b="1">
                 <a:solidFill>
                   <a:srgbClr val="001957"/>
@@ -1223,7 +1223,7 @@
       </p:sp>
       <p:sp>
         <p:nvSpPr>
-          <p:cNvPr id="133" name="Titel der Präsentation"/>
+          <p:cNvPr id="127" name="Titel der Präsentation"/>
           <p:cNvSpPr txBox="1"/>
           <p:nvPr userDrawn="1"/>
         </p:nvSpPr>
@@ -1251,7 +1251,7 @@
             </a:r>
           </a:p>
           <a:p>
-            <a:fld id="{B6F15528-21DE-4FAA-801E-634DDDAF4B132}" type="datetime1">
+            <a:fld id="{466BE564-E158-4F48-A499-4A9A6AA7528E}" type="datetime1">
               <a:rPr lang="de-DE" sz="1100" b="0">
                 <a:solidFill>
                   <a:srgbClr val="001957"/>
@@ -1264,7 +1264,7 @@
       </p:sp>
       <p:pic>
         <p:nvPicPr>
-          <p:cNvPr id="134" name="Logo" descr="R+V Logo"/>
+          <p:cNvPr id="128" name="Logo" descr="R+V Logo"/>
           <p:cNvPicPr>
             <a:picLocks noChangeAspect="1"/>
           </p:cNvPicPr>

</xml_diff>

<commit_message>
PPTX-Vorlage: Foliengröße ohne Typ screen4x3
Co-Authored-By: Claude Opus 5.5 (1M context) <noreply@anthropic.com>
Claude-Session: https://claude.ai/code/session_01M4rEXzL8UEswz3hhtHJS6u
</commit_message>
<xml_diff>
--- a/templates/ruv.pptx
+++ b/templates/ruv.pptx
@@ -5,7 +5,7 @@
     <p:sldMasterId id="2147483648" r:id="rId1"/>
   </p:sldMasterIdLst>
   <p:sldIdLst/>
-  <p:sldSz cx="12192000" cy="6858000" type="screen4x3"/>
+  <p:sldSz cx="12192000" cy="6858000"/>
   <p:notesSz cx="6858000" cy="9144000"/>
   <p:defaultTextStyle>
     <a:defPPr>
@@ -546,7 +546,7 @@
           <a:bodyPr wrap="square" lIns="0" tIns="0" rIns="0" bIns="0" anchor="t"/>
           <a:lstStyle/>
           <a:p>
-            <a:fld id="{8E0C8BB0-4148-4D49-B4EA-77B9D8D7DE0D}" type="slidenum">
+            <a:fld id="{E4A256FE-9E3D-4635-8E49-99D65348C7CB}" type="slidenum">
               <a:rPr lang="de-DE" sz="1100" b="1">
                 <a:solidFill>
                   <a:srgbClr val="001957"/>
@@ -587,7 +587,7 @@
             </a:r>
           </a:p>
           <a:p>
-            <a:fld id="{70727C23-D070-4A6E-A4B8-0208138AD74C}" type="datetime1">
+            <a:fld id="{8FC7F01A-C734-4F5A-9F8D-B637C2F59292}" type="datetime1">
               <a:rPr lang="de-DE" sz="1100" b="0">
                 <a:solidFill>
                   <a:srgbClr val="001957"/>
@@ -994,7 +994,7 @@
           <a:bodyPr wrap="square" lIns="0" tIns="0" rIns="0" bIns="0" anchor="t"/>
           <a:lstStyle/>
           <a:p>
-            <a:fld id="{2B69EE39-67D0-4DEE-B0CB-E81B90525783}" type="slidenum">
+            <a:fld id="{5D2820C3-5144-4AE0-8AF3-0F99C99385CF}" type="slidenum">
               <a:rPr lang="de-DE" sz="1100" b="1">
                 <a:solidFill>
                   <a:srgbClr val="001957"/>
@@ -1035,7 +1035,7 @@
             </a:r>
           </a:p>
           <a:p>
-            <a:fld id="{C7388E26-8403-4CAF-A845-85D84EF990BD}" type="datetime1">
+            <a:fld id="{0976834D-D4E0-499B-8EB4-642BFEC9D5C6}" type="datetime1">
               <a:rPr lang="de-DE" sz="1100" b="0">
                 <a:solidFill>
                   <a:srgbClr val="001957"/>
@@ -1210,7 +1210,7 @@
           <a:bodyPr wrap="square" lIns="0" tIns="0" rIns="0" bIns="0" anchor="t"/>
           <a:lstStyle/>
           <a:p>
-            <a:fld id="{A3C1BBF4-CCF8-4197-ACDF-52B3CC889267}" type="slidenum">
+            <a:fld id="{1058FBCA-CDA7-4187-A29C-1F961DA6DAF4}" type="slidenum">
               <a:rPr lang="de-DE" sz="1100" b="1">
                 <a:solidFill>
                   <a:srgbClr val="001957"/>
@@ -1251,7 +1251,7 @@
             </a:r>
           </a:p>
           <a:p>
-            <a:fld id="{466BE564-E158-4F48-A499-4A9A6AA7528E}" type="datetime1">
+            <a:fld id="{A0644FF7-94C9-479E-9834-A3EFB9532505}" type="datetime1">
               <a:rPr lang="de-DE" sz="1100" b="0">
                 <a:solidFill>
                   <a:srgbClr val="001957"/>

</xml_diff>